<commit_message>
Add the 3-minute ad and credit my role in the deck and notes
- Build60-ad.mp4: commercial-style cut, beat-synced to 120 BPM music,
  narrated by Kokoro "Michael".
- Growth plan: "How I built it" on slide 1, a "My role" strip on slide 5.
- Submission notes: a "How I worked with AI" section with the ideas and
  calls that were mine, plus what I did myself.

Co-Authored-By: Claude Opus 5.5 <noreply@anthropic.com>
</commit_message>
<xml_diff>
--- a/submission/Build60-Growth-Plan.pptx
+++ b/submission/Build60-Growth-Plan.pptx
@@ -111,27 +111,27 @@
   <p:extLst>
     <p:ext uri="{521415D9-36F7-43E2-AB2F-B90AF26B5E84}">
       <p14:sectionLst xmlns:p14="http://schemas.microsoft.com/office/powerpoint/2010/main">
-        <p14:section name="Student" id="{e8f3d379-3f8f-c986-8551-90afc7deebf2}">
+        <p14:section name="Student" id="{a61bd5ac-c8f6-a25c-2a85-15affddb227c}">
           <p14:sldIdLst>
             <p14:sldId id="256"/>
           </p14:sldIdLst>
         </p14:section>
-        <p14:section name="Plan" id="{6af4d118-bdfa-b886-896b-1e78f3f2ad41}">
+        <p14:section name="Plan" id="{fbdf0ff7-9d41-04c0-6108-c97d27924a75}">
           <p14:sldIdLst>
             <p14:sldId id="257"/>
           </p14:sldIdLst>
         </p14:section>
-        <p14:section name="Math" id="{8228a84b-5859-28d0-7de9-fa8d06408d89}">
+        <p14:section name="Math" id="{49b14ecb-e7c3-267d-5049-c4d9bc5b7661}">
           <p14:sldIdLst>
             <p14:sldId id="258"/>
           </p14:sldIdLst>
         </p14:section>
-        <p14:section name="Week" id="{0eabf7ad-2da2-f97c-d5a9-b39cfe4c582a}">
+        <p14:section name="Week" id="{b51cada3-ef5b-d8cd-f4b7-db74aa5f2b70}">
           <p14:sldIdLst>
             <p14:sldId id="259"/>
           </p14:sldIdLst>
         </p14:section>
-        <p14:section name="Asset" id="{a3a0d2e2-94af-9d39-0b61-16c2897f94fd}">
+        <p14:section name="Asset" id="{cb895419-eecd-0269-db0b-75ebfae13724}">
           <p14:sldIdLst>
             <p14:sldId id="260"/>
           </p14:sldIdLst>
@@ -822,7 +822,7 @@
           <a:p>
             <a:r>
               <a:rPr lang="en-US" dirty="0"/>
-              <a:t>Who I'm targeting: final-year engineering students in tier-2 and tier-3 colleges across the South, CSE, IT and ECE first. Why they care: it's placement season and their resumes look identical. What makes them register: a concrete outcome — a deployed project link — for one free hour, a 30-second form, and seeing their friends and college on a live leaderboard.</a:t>
+              <a:t>How I built it: I used Claude Code as my builder. I gave it more than 40 instructions over two sessions — what to build, what to cut, what to check, and what wasn't good enough yet. The timed challenge was my idea, I kept everything on free tools, and I reviewed every result before it stayed. Who I'm targeting: final-year engineering students in tier-2 and tier-3 colleges across the South, CSE, IT and ECE first. Why they care: it's placement season and their resumes look identical. What makes them register: a concrete outcome — a deployed project link — for one free hour, a 30-second form, and seeing their friends and college on a live leaderboard.</a:t>
             </a:r>
             <a:endParaRPr lang="en-US" dirty="0"/>
           </a:p>
@@ -1174,7 +1174,7 @@
           <a:p>
             <a:r>
               <a:rPr lang="en-US" dirty="0"/>
-              <a:t>The one thing I built is the engine that runs this plan, not just a landing page: a 30-second sign-up with a live seat meter, personal referral links that preview with your name and college, a college leaderboard with rewards, an ambassador kit that writes tracked WhatsApp messages, an admin dashboard showing plan versus actual and conversion per source, and a 60-minute challenge whose shareable result cards bring in the next wave. It has 32 automated tests, no known production vulnerabilities, and runs free.</a:t>
+              <a:t>The one thing I built is the engine that runs this plan, not just a landing page: a 30-second sign-up with a live seat meter, personal referral links that preview with your name and college, a college leaderboard with rewards, an ambassador kit that writes tracked WhatsApp messages, an admin dashboard showing plan versus actual and conversion per source, and a 60-minute challenge whose shareable result cards bring in the next wave. It has 32 automated tests, no known production vulnerabilities, and runs free. My role: I directed and Claude Code built. The timed challenge with AI-generated variants, the choice of local or API models behind a password, and the full redesign were my ideas, and I checked every build against the brief.</a:t>
             </a:r>
             <a:endParaRPr lang="en-US" dirty="0"/>
           </a:p>
@@ -2100,7 +2100,304 @@
       </p:sp>
       <p:sp>
         <p:nvSpPr>
-          <p:cNvPr id="5" name="Student card"/>
+          <p:cNvPr id="5" name="Text 3"/>
+          <p:cNvSpPr txBox="1"/>
+          <p:nvPr/>
+        </p:nvSpPr>
+        <p:spPr>
+          <a:xfrm>
+            <a:off x="548640" y="4069080"/>
+            <a:ext cx="5760720" cy="274320"/>
+          </a:xfrm>
+          <a:prstGeom prst="rect">
+            <a:avLst/>
+          </a:prstGeom>
+          <a:noFill/>
+          <a:ln/>
+        </p:spPr>
+        <p:txBody>
+          <a:bodyPr wrap="square" lIns="0" tIns="0" rIns="0" bIns="0" rtlCol="0" anchor="ctr"/>
+          <a:lstStyle/>
+          <a:p>
+            <a:pPr indent="0" marL="0">
+              <a:buNone/>
+            </a:pPr>
+            <a:r>
+              <a:rPr lang="en-US" sz="1100" b="1" dirty="0">
+                <a:solidFill>
+                  <a:schemeClr val="accent2"/>
+                </a:solidFill>
+                <a:latin typeface="Courier New" pitchFamily="34" charset="0"/>
+                <a:ea typeface="Courier New" pitchFamily="34" charset="-122"/>
+                <a:cs typeface="Courier New" pitchFamily="34" charset="-120"/>
+              </a:rPr>
+              <a:t>HOW I BUILT IT</a:t>
+            </a:r>
+            <a:endParaRPr lang="en-US" sz="1100" dirty="0"/>
+          </a:p>
+        </p:txBody>
+      </p:sp>
+      <p:sp>
+        <p:nvSpPr>
+          <p:cNvPr id="6" name="Split 1"/>
+          <p:cNvSpPr/>
+          <p:nvPr/>
+        </p:nvSpPr>
+        <p:spPr>
+          <a:xfrm>
+            <a:off x="548640" y="4434840"/>
+            <a:ext cx="1810512" cy="1554480"/>
+          </a:xfrm>
+          <a:prstGeom prst="roundRect">
+            <a:avLst>
+              <a:gd name="adj" fmla="val 3529"/>
+            </a:avLst>
+          </a:prstGeom>
+          <a:solidFill>
+            <a:schemeClr val="tx1"/>
+          </a:solidFill>
+          <a:ln w="15875">
+            <a:solidFill>
+              <a:schemeClr val="accent2"/>
+            </a:solidFill>
+            <a:prstDash val="solid"/>
+          </a:ln>
+        </p:spPr>
+      </p:sp>
+      <p:sp>
+        <p:nvSpPr>
+          <p:cNvPr id="7" name="Split 1 text"/>
+          <p:cNvSpPr txBox="1"/>
+          <p:nvPr/>
+        </p:nvSpPr>
+        <p:spPr>
+          <a:xfrm>
+            <a:off x="713232" y="4553712"/>
+            <a:ext cx="1481328" cy="1344168"/>
+          </a:xfrm>
+          <a:prstGeom prst="rect">
+            <a:avLst/>
+          </a:prstGeom>
+          <a:noFill/>
+          <a:ln/>
+        </p:spPr>
+        <p:txBody>
+          <a:bodyPr wrap="square" lIns="0" tIns="0" rIns="0" bIns="0" rtlCol="0" anchor="t"/>
+          <a:lstStyle/>
+          <a:p>
+            <a:pPr indent="0" marL="0">
+              <a:spcAft>
+                <a:spcPts val="400"/>
+              </a:spcAft>
+              <a:buNone/>
+            </a:pPr>
+            <a:r>
+              <a:rPr lang="en-US" sz="2400" dirty="0">
+                <a:solidFill>
+                  <a:schemeClr val="accent2"/>
+                </a:solidFill>
+                <a:latin typeface="Cambria" pitchFamily="34" charset="0"/>
+                <a:ea typeface="Cambria" pitchFamily="34" charset="-122"/>
+                <a:cs typeface="Cambria" pitchFamily="34" charset="-120"/>
+              </a:rPr>
+              <a:t>40+</a:t>
+            </a:r>
+            <a:endParaRPr lang="en-US" sz="2400" dirty="0"/>
+          </a:p>
+          <a:p>
+            <a:pPr indent="0" marL="0">
+              <a:spcAft>
+                <a:spcPts val="400"/>
+              </a:spcAft>
+              <a:buNone/>
+            </a:pPr>
+            <a:r>
+              <a:rPr lang="en-US" sz="1200" dirty="0">
+                <a:solidFill>
+                  <a:schemeClr val="accent5"/>
+                </a:solidFill>
+              </a:rPr>
+              <a:t>instructions I gave Claude Code: what to build, cut, check and redo</a:t>
+            </a:r>
+            <a:endParaRPr lang="en-US" sz="2400" dirty="0"/>
+          </a:p>
+        </p:txBody>
+      </p:sp>
+      <p:sp>
+        <p:nvSpPr>
+          <p:cNvPr id="8" name="Split 2"/>
+          <p:cNvSpPr/>
+          <p:nvPr/>
+        </p:nvSpPr>
+        <p:spPr>
+          <a:xfrm>
+            <a:off x="2523744" y="4434840"/>
+            <a:ext cx="1810512" cy="1554480"/>
+          </a:xfrm>
+          <a:prstGeom prst="roundRect">
+            <a:avLst>
+              <a:gd name="adj" fmla="val 3529"/>
+            </a:avLst>
+          </a:prstGeom>
+          <a:solidFill>
+            <a:schemeClr val="tx1"/>
+          </a:solidFill>
+          <a:ln w="15875">
+            <a:solidFill>
+              <a:schemeClr val="tx2"/>
+            </a:solidFill>
+            <a:prstDash val="solid"/>
+          </a:ln>
+        </p:spPr>
+      </p:sp>
+      <p:sp>
+        <p:nvSpPr>
+          <p:cNvPr id="9" name="Split 2 text"/>
+          <p:cNvSpPr txBox="1"/>
+          <p:nvPr/>
+        </p:nvSpPr>
+        <p:spPr>
+          <a:xfrm>
+            <a:off x="2688336" y="4553712"/>
+            <a:ext cx="1481328" cy="1344168"/>
+          </a:xfrm>
+          <a:prstGeom prst="rect">
+            <a:avLst/>
+          </a:prstGeom>
+          <a:noFill/>
+          <a:ln/>
+        </p:spPr>
+        <p:txBody>
+          <a:bodyPr wrap="square" lIns="0" tIns="0" rIns="0" bIns="0" rtlCol="0" anchor="t"/>
+          <a:lstStyle/>
+          <a:p>
+            <a:pPr indent="0" marL="0">
+              <a:spcAft>
+                <a:spcPts val="400"/>
+              </a:spcAft>
+              <a:buNone/>
+            </a:pPr>
+            <a:r>
+              <a:rPr lang="en-US" sz="2400" dirty="0">
+                <a:solidFill>
+                  <a:schemeClr val="bg1"/>
+                </a:solidFill>
+                <a:latin typeface="Cambria" pitchFamily="34" charset="0"/>
+                <a:ea typeface="Cambria" pitchFamily="34" charset="-122"/>
+                <a:cs typeface="Cambria" pitchFamily="34" charset="-120"/>
+              </a:rPr>
+              <a:t>My calls</a:t>
+            </a:r>
+            <a:endParaRPr lang="en-US" sz="2400" dirty="0"/>
+          </a:p>
+          <a:p>
+            <a:pPr indent="0" marL="0">
+              <a:spcAft>
+                <a:spcPts val="400"/>
+              </a:spcAft>
+              <a:buNone/>
+            </a:pPr>
+            <a:r>
+              <a:rPr lang="en-US" sz="1200" dirty="0">
+                <a:solidFill>
+                  <a:schemeClr val="accent5"/>
+                </a:solidFill>
+              </a:rPr>
+              <a:t>the timed-challenge idea, free tools only, and the quality bar</a:t>
+            </a:r>
+            <a:endParaRPr lang="en-US" sz="2400" dirty="0"/>
+          </a:p>
+        </p:txBody>
+      </p:sp>
+      <p:sp>
+        <p:nvSpPr>
+          <p:cNvPr id="10" name="Split 3"/>
+          <p:cNvSpPr/>
+          <p:nvPr/>
+        </p:nvSpPr>
+        <p:spPr>
+          <a:xfrm>
+            <a:off x="4498848" y="4434840"/>
+            <a:ext cx="1810512" cy="1554480"/>
+          </a:xfrm>
+          <a:prstGeom prst="roundRect">
+            <a:avLst>
+              <a:gd name="adj" fmla="val 3529"/>
+            </a:avLst>
+          </a:prstGeom>
+          <a:solidFill>
+            <a:schemeClr val="tx1"/>
+          </a:solidFill>
+          <a:ln w="15875">
+            <a:solidFill>
+              <a:schemeClr val="tx2"/>
+            </a:solidFill>
+            <a:prstDash val="solid"/>
+          </a:ln>
+        </p:spPr>
+      </p:sp>
+      <p:sp>
+        <p:nvSpPr>
+          <p:cNvPr id="11" name="Split 3 text"/>
+          <p:cNvSpPr txBox="1"/>
+          <p:nvPr/>
+        </p:nvSpPr>
+        <p:spPr>
+          <a:xfrm>
+            <a:off x="4663440" y="4553712"/>
+            <a:ext cx="1481328" cy="1344168"/>
+          </a:xfrm>
+          <a:prstGeom prst="rect">
+            <a:avLst/>
+          </a:prstGeom>
+          <a:noFill/>
+          <a:ln/>
+        </p:spPr>
+        <p:txBody>
+          <a:bodyPr wrap="square" lIns="0" tIns="0" rIns="0" bIns="0" rtlCol="0" anchor="t"/>
+          <a:lstStyle/>
+          <a:p>
+            <a:pPr indent="0" marL="0">
+              <a:spcAft>
+                <a:spcPts val="400"/>
+              </a:spcAft>
+              <a:buNone/>
+            </a:pPr>
+            <a:r>
+              <a:rPr lang="en-US" sz="2400" dirty="0">
+                <a:solidFill>
+                  <a:schemeClr val="bg1"/>
+                </a:solidFill>
+                <a:latin typeface="Cambria" pitchFamily="34" charset="0"/>
+                <a:ea typeface="Cambria" pitchFamily="34" charset="-122"/>
+                <a:cs typeface="Cambria" pitchFamily="34" charset="-120"/>
+              </a:rPr>
+              <a:t>AI’s part</a:t>
+            </a:r>
+            <a:endParaRPr lang="en-US" sz="2400" dirty="0"/>
+          </a:p>
+          <a:p>
+            <a:pPr indent="0" marL="0">
+              <a:spcAft>
+                <a:spcPts val="400"/>
+              </a:spcAft>
+              <a:buNone/>
+            </a:pPr>
+            <a:r>
+              <a:rPr lang="en-US" sz="1200" dirty="0">
+                <a:solidFill>
+                  <a:schemeClr val="accent5"/>
+                </a:solidFill>
+              </a:rPr>
+              <a:t>writing the code and first drafts, which I reviewed and sent back when wrong</a:t>
+            </a:r>
+            <a:endParaRPr lang="en-US" sz="2400" dirty="0"/>
+          </a:p>
+        </p:txBody>
+      </p:sp>
+      <p:sp>
+        <p:nvSpPr>
+          <p:cNvPr id="12" name="Student card"/>
           <p:cNvSpPr/>
           <p:nvPr/>
         </p:nvSpPr>
@@ -2134,7 +2431,7 @@
       </p:sp>
       <p:sp>
         <p:nvSpPr>
-          <p:cNvPr id="6" name="Text 4"/>
+          <p:cNvPr id="13" name="Text 11"/>
           <p:cNvSpPr txBox="1"/>
           <p:nvPr/>
         </p:nvSpPr>
@@ -2173,7 +2470,7 @@
       </p:sp>
       <p:sp>
         <p:nvSpPr>
-          <p:cNvPr id="7" name="Who icon"/>
+          <p:cNvPr id="14" name="Who icon"/>
           <p:cNvSpPr/>
           <p:nvPr/>
         </p:nvSpPr>
@@ -2198,7 +2495,7 @@
       </p:sp>
       <p:pic>
         <p:nvPicPr>
-          <p:cNvPr id="8" name="Who icon icon" descr="preencoded.png">    </p:cNvPr>
+          <p:cNvPr id="15" name="Who icon icon" descr="preencoded.png">    </p:cNvPr>
           <p:cNvPicPr>
             <a:picLocks noChangeAspect="1"/>
           </p:cNvPicPr>
@@ -2222,7 +2519,7 @@
       </p:pic>
       <p:sp>
         <p:nvSpPr>
-          <p:cNvPr id="9" name="Who text"/>
+          <p:cNvPr id="16" name="Who text"/>
           <p:cNvSpPr txBox="1"/>
           <p:nvPr/>
         </p:nvSpPr>
@@ -2281,7 +2578,7 @@
       </p:sp>
       <p:sp>
         <p:nvSpPr>
-          <p:cNvPr id="10" name="Why they care icon"/>
+          <p:cNvPr id="17" name="Why they care icon"/>
           <p:cNvSpPr/>
           <p:nvPr/>
         </p:nvSpPr>
@@ -2306,7 +2603,7 @@
       </p:sp>
       <p:pic>
         <p:nvPicPr>
-          <p:cNvPr id="11" name="Why they care icon icon" descr="preencoded.png">    </p:cNvPr>
+          <p:cNvPr id="18" name="Why they care icon icon" descr="preencoded.png">    </p:cNvPr>
           <p:cNvPicPr>
             <a:picLocks noChangeAspect="1"/>
           </p:cNvPicPr>
@@ -2330,7 +2627,7 @@
       </p:pic>
       <p:sp>
         <p:nvSpPr>
-          <p:cNvPr id="12" name="Why they care text"/>
+          <p:cNvPr id="19" name="Why they care text"/>
           <p:cNvSpPr txBox="1"/>
           <p:nvPr/>
         </p:nvSpPr>
@@ -2389,7 +2686,7 @@
       </p:sp>
       <p:sp>
         <p:nvSpPr>
-          <p:cNvPr id="13" name="What makes them register icon"/>
+          <p:cNvPr id="20" name="What makes them register icon"/>
           <p:cNvSpPr/>
           <p:nvPr/>
         </p:nvSpPr>
@@ -2414,7 +2711,7 @@
       </p:sp>
       <p:pic>
         <p:nvPicPr>
-          <p:cNvPr id="14" name="What makes them register icon icon" descr="preencoded.png">    </p:cNvPr>
+          <p:cNvPr id="21" name="What makes them register icon icon" descr="preencoded.png">    </p:cNvPr>
           <p:cNvPicPr>
             <a:picLocks noChangeAspect="1"/>
           </p:cNvPicPr>
@@ -2438,7 +2735,7 @@
       </p:pic>
       <p:sp>
         <p:nvSpPr>
-          <p:cNvPr id="15" name="What makes them register text"/>
+          <p:cNvPr id="22" name="What makes them register text"/>
           <p:cNvSpPr txBox="1"/>
           <p:nvPr/>
         </p:nvSpPr>
@@ -6647,11 +6944,11 @@
         <p:spPr>
           <a:xfrm>
             <a:off x="548640" y="1600200"/>
-            <a:ext cx="3520440" cy="1325880"/>
+            <a:ext cx="3520440" cy="1143000"/>
           </a:xfrm>
           <a:prstGeom prst="roundRect">
             <a:avLst>
-              <a:gd name="adj" fmla="val 4138"/>
+              <a:gd name="adj" fmla="val 4800"/>
             </a:avLst>
           </a:prstGeom>
           <a:solidFill>
@@ -6680,7 +6977,7 @@
         </p:nvSpPr>
         <p:spPr>
           <a:xfrm>
-            <a:off x="777240" y="1828800"/>
+            <a:off x="777240" y="1783080"/>
             <a:ext cx="502920" cy="502920"/>
           </a:xfrm>
           <a:prstGeom prst="ellipse">
@@ -6713,7 +7010,7 @@
         </p:blipFill>
         <p:spPr>
           <a:xfrm>
-            <a:off x="887882" y="1939442"/>
+            <a:off x="887882" y="1893722"/>
             <a:ext cx="281635" cy="281635"/>
           </a:xfrm>
           <a:prstGeom prst="rect">
@@ -6729,8 +7026,8 @@
         </p:nvSpPr>
         <p:spPr>
           <a:xfrm>
-            <a:off x="1463040" y="1764792"/>
-            <a:ext cx="2423160" cy="1005840"/>
+            <a:off x="1463040" y="1728216"/>
+            <a:ext cx="2423160" cy="914400"/>
           </a:xfrm>
           <a:prstGeom prst="rect">
             <a:avLst/>
@@ -6789,11 +7086,11 @@
         <p:spPr>
           <a:xfrm>
             <a:off x="4343400" y="1600200"/>
-            <a:ext cx="3520440" cy="1325880"/>
+            <a:ext cx="3520440" cy="1143000"/>
           </a:xfrm>
           <a:prstGeom prst="roundRect">
             <a:avLst>
-              <a:gd name="adj" fmla="val 4138"/>
+              <a:gd name="adj" fmla="val 4800"/>
             </a:avLst>
           </a:prstGeom>
           <a:solidFill>
@@ -6822,7 +7119,7 @@
         </p:nvSpPr>
         <p:spPr>
           <a:xfrm>
-            <a:off x="4572000" y="1828800"/>
+            <a:off x="4572000" y="1783080"/>
             <a:ext cx="502920" cy="502920"/>
           </a:xfrm>
           <a:prstGeom prst="ellipse">
@@ -6855,7 +7152,7 @@
         </p:blipFill>
         <p:spPr>
           <a:xfrm>
-            <a:off x="4682642" y="1939442"/>
+            <a:off x="4682642" y="1893722"/>
             <a:ext cx="281635" cy="281635"/>
           </a:xfrm>
           <a:prstGeom prst="rect">
@@ -6871,8 +7168,8 @@
         </p:nvSpPr>
         <p:spPr>
           <a:xfrm>
-            <a:off x="5257800" y="1764792"/>
-            <a:ext cx="2423160" cy="1005840"/>
+            <a:off x="5257800" y="1728216"/>
+            <a:ext cx="2423160" cy="914400"/>
           </a:xfrm>
           <a:prstGeom prst="rect">
             <a:avLst/>
@@ -6930,12 +7227,12 @@
         </p:nvSpPr>
         <p:spPr>
           <a:xfrm>
-            <a:off x="548640" y="3136392"/>
-            <a:ext cx="3520440" cy="1325880"/>
+            <a:off x="548640" y="2898648"/>
+            <a:ext cx="3520440" cy="1143000"/>
           </a:xfrm>
           <a:prstGeom prst="roundRect">
             <a:avLst>
-              <a:gd name="adj" fmla="val 4138"/>
+              <a:gd name="adj" fmla="val 4800"/>
             </a:avLst>
           </a:prstGeom>
           <a:solidFill>
@@ -6964,7 +7261,7 @@
         </p:nvSpPr>
         <p:spPr>
           <a:xfrm>
-            <a:off x="777240" y="3364992"/>
+            <a:off x="777240" y="3081528"/>
             <a:ext cx="502920" cy="502920"/>
           </a:xfrm>
           <a:prstGeom prst="ellipse">
@@ -6997,7 +7294,7 @@
         </p:blipFill>
         <p:spPr>
           <a:xfrm>
-            <a:off x="887882" y="3475634"/>
+            <a:off x="887882" y="3192170"/>
             <a:ext cx="281635" cy="281635"/>
           </a:xfrm>
           <a:prstGeom prst="rect">
@@ -7013,8 +7310,8 @@
         </p:nvSpPr>
         <p:spPr>
           <a:xfrm>
-            <a:off x="1463040" y="3300984"/>
-            <a:ext cx="2423160" cy="1005840"/>
+            <a:off x="1463040" y="3026664"/>
+            <a:ext cx="2423160" cy="914400"/>
           </a:xfrm>
           <a:prstGeom prst="rect">
             <a:avLst/>
@@ -7072,12 +7369,12 @@
         </p:nvSpPr>
         <p:spPr>
           <a:xfrm>
-            <a:off x="4343400" y="3136392"/>
-            <a:ext cx="3520440" cy="1325880"/>
+            <a:off x="4343400" y="2898648"/>
+            <a:ext cx="3520440" cy="1143000"/>
           </a:xfrm>
           <a:prstGeom prst="roundRect">
             <a:avLst>
-              <a:gd name="adj" fmla="val 4138"/>
+              <a:gd name="adj" fmla="val 4800"/>
             </a:avLst>
           </a:prstGeom>
           <a:solidFill>
@@ -7106,7 +7403,7 @@
         </p:nvSpPr>
         <p:spPr>
           <a:xfrm>
-            <a:off x="4572000" y="3364992"/>
+            <a:off x="4572000" y="3081528"/>
             <a:ext cx="502920" cy="502920"/>
           </a:xfrm>
           <a:prstGeom prst="ellipse">
@@ -7139,7 +7436,7 @@
         </p:blipFill>
         <p:spPr>
           <a:xfrm>
-            <a:off x="4682642" y="3475634"/>
+            <a:off x="4682642" y="3192170"/>
             <a:ext cx="281635" cy="281635"/>
           </a:xfrm>
           <a:prstGeom prst="rect">
@@ -7155,8 +7452,8 @@
         </p:nvSpPr>
         <p:spPr>
           <a:xfrm>
-            <a:off x="5257800" y="3300984"/>
-            <a:ext cx="2423160" cy="1005840"/>
+            <a:off x="5257800" y="3026664"/>
+            <a:ext cx="2423160" cy="914400"/>
           </a:xfrm>
           <a:prstGeom prst="rect">
             <a:avLst/>
@@ -7214,12 +7511,12 @@
         </p:nvSpPr>
         <p:spPr>
           <a:xfrm>
-            <a:off x="548640" y="4672584"/>
-            <a:ext cx="3520440" cy="1325880"/>
+            <a:off x="548640" y="4197096"/>
+            <a:ext cx="3520440" cy="1143000"/>
           </a:xfrm>
           <a:prstGeom prst="roundRect">
             <a:avLst>
-              <a:gd name="adj" fmla="val 4138"/>
+              <a:gd name="adj" fmla="val 4800"/>
             </a:avLst>
           </a:prstGeom>
           <a:solidFill>
@@ -7248,7 +7545,7 @@
         </p:nvSpPr>
         <p:spPr>
           <a:xfrm>
-            <a:off x="777240" y="4901184"/>
+            <a:off x="777240" y="4379976"/>
             <a:ext cx="502920" cy="502920"/>
           </a:xfrm>
           <a:prstGeom prst="ellipse">
@@ -7281,7 +7578,7 @@
         </p:blipFill>
         <p:spPr>
           <a:xfrm>
-            <a:off x="887882" y="5011826"/>
+            <a:off x="887882" y="4490618"/>
             <a:ext cx="281635" cy="281635"/>
           </a:xfrm>
           <a:prstGeom prst="rect">
@@ -7297,8 +7594,8 @@
         </p:nvSpPr>
         <p:spPr>
           <a:xfrm>
-            <a:off x="1463040" y="4837176"/>
-            <a:ext cx="2423160" cy="1005840"/>
+            <a:off x="1463040" y="4325112"/>
+            <a:ext cx="2423160" cy="914400"/>
           </a:xfrm>
           <a:prstGeom prst="rect">
             <a:avLst/>
@@ -7356,12 +7653,12 @@
         </p:nvSpPr>
         <p:spPr>
           <a:xfrm>
-            <a:off x="4343400" y="4672584"/>
-            <a:ext cx="3520440" cy="1325880"/>
+            <a:off x="4343400" y="4197096"/>
+            <a:ext cx="3520440" cy="1143000"/>
           </a:xfrm>
           <a:prstGeom prst="roundRect">
             <a:avLst>
-              <a:gd name="adj" fmla="val 4138"/>
+              <a:gd name="adj" fmla="val 4800"/>
             </a:avLst>
           </a:prstGeom>
           <a:solidFill>
@@ -7390,7 +7687,7 @@
         </p:nvSpPr>
         <p:spPr>
           <a:xfrm>
-            <a:off x="4572000" y="4901184"/>
+            <a:off x="4572000" y="4379976"/>
             <a:ext cx="502920" cy="502920"/>
           </a:xfrm>
           <a:prstGeom prst="ellipse">
@@ -7423,7 +7720,7 @@
         </p:blipFill>
         <p:spPr>
           <a:xfrm>
-            <a:off x="4682642" y="5011826"/>
+            <a:off x="4682642" y="4490618"/>
             <a:ext cx="281635" cy="281635"/>
           </a:xfrm>
           <a:prstGeom prst="rect">
@@ -7439,8 +7736,8 @@
         </p:nvSpPr>
         <p:spPr>
           <a:xfrm>
-            <a:off x="5257800" y="4837176"/>
-            <a:ext cx="2423160" cy="1005840"/>
+            <a:off x="5257800" y="4325112"/>
+            <a:ext cx="2423160" cy="914400"/>
           </a:xfrm>
           <a:prstGeom prst="rect">
             <a:avLst/>
@@ -7499,7 +7796,7 @@
         <p:spPr>
           <a:xfrm>
             <a:off x="8183880" y="1600200"/>
-            <a:ext cx="3456432" cy="4398264"/>
+            <a:ext cx="3456432" cy="3739896"/>
           </a:xfrm>
           <a:prstGeom prst="roundRect">
             <a:avLst>
@@ -7532,8 +7829,8 @@
         </p:nvSpPr>
         <p:spPr>
           <a:xfrm>
-            <a:off x="8458200" y="1783080"/>
-            <a:ext cx="2926080" cy="566928"/>
+            <a:off x="8458200" y="1737360"/>
+            <a:ext cx="2926080" cy="502920"/>
           </a:xfrm>
           <a:prstGeom prst="rect">
             <a:avLst/>
@@ -7549,7 +7846,7 @@
               <a:buNone/>
             </a:pPr>
             <a:r>
-              <a:rPr lang="en-US" sz="3600" dirty="0">
+              <a:rPr lang="en-US" sz="3200" dirty="0">
                 <a:solidFill>
                   <a:schemeClr val="accent2"/>
                 </a:solidFill>
@@ -7559,7 +7856,7 @@
               </a:rPr>
               <a:t>32</a:t>
             </a:r>
-            <a:endParaRPr lang="en-US" sz="3600" dirty="0"/>
+            <a:endParaRPr lang="en-US" sz="3200" dirty="0"/>
           </a:p>
         </p:txBody>
       </p:sp>
@@ -7571,8 +7868,8 @@
         </p:nvSpPr>
         <p:spPr>
           <a:xfrm>
-            <a:off x="8458200" y="2331720"/>
-            <a:ext cx="2926080" cy="384048"/>
+            <a:off x="8458200" y="2212848"/>
+            <a:ext cx="2926080" cy="292608"/>
           </a:xfrm>
           <a:prstGeom prst="rect">
             <a:avLst/>
@@ -7607,8 +7904,8 @@
         </p:nvSpPr>
         <p:spPr>
           <a:xfrm>
-            <a:off x="8458200" y="2807208"/>
-            <a:ext cx="2926080" cy="566928"/>
+            <a:off x="8458200" y="2578608"/>
+            <a:ext cx="2926080" cy="502920"/>
           </a:xfrm>
           <a:prstGeom prst="rect">
             <a:avLst/>
@@ -7624,7 +7921,7 @@
               <a:buNone/>
             </a:pPr>
             <a:r>
-              <a:rPr lang="en-US" sz="3600" dirty="0">
+              <a:rPr lang="en-US" sz="3200" dirty="0">
                 <a:solidFill>
                   <a:schemeClr val="accent2"/>
                 </a:solidFill>
@@ -7634,7 +7931,7 @@
               </a:rPr>
               <a:t>0</a:t>
             </a:r>
-            <a:endParaRPr lang="en-US" sz="3600" dirty="0"/>
+            <a:endParaRPr lang="en-US" sz="3200" dirty="0"/>
           </a:p>
         </p:txBody>
       </p:sp>
@@ -7646,8 +7943,8 @@
         </p:nvSpPr>
         <p:spPr>
           <a:xfrm>
-            <a:off x="8458200" y="3355848"/>
-            <a:ext cx="2926080" cy="384048"/>
+            <a:off x="8458200" y="3054096"/>
+            <a:ext cx="2926080" cy="292608"/>
           </a:xfrm>
           <a:prstGeom prst="rect">
             <a:avLst/>
@@ -7668,7 +7965,7 @@
                   <a:schemeClr val="bg2"/>
                 </a:solidFill>
               </a:rPr>
-              <a:t>known vulnerabilities in production dependencies</a:t>
+              <a:t>known production vulnerabilities</a:t>
             </a:r>
             <a:endParaRPr lang="en-US" sz="1300" dirty="0"/>
           </a:p>
@@ -7682,8 +7979,8 @@
         </p:nvSpPr>
         <p:spPr>
           <a:xfrm>
-            <a:off x="8458200" y="3831336"/>
-            <a:ext cx="2926080" cy="566928"/>
+            <a:off x="8458200" y="3419856"/>
+            <a:ext cx="2926080" cy="502920"/>
           </a:xfrm>
           <a:prstGeom prst="rect">
             <a:avLst/>
@@ -7699,7 +7996,7 @@
               <a:buNone/>
             </a:pPr>
             <a:r>
-              <a:rPr lang="en-US" sz="3600" dirty="0">
+              <a:rPr lang="en-US" sz="3200" dirty="0">
                 <a:solidFill>
                   <a:schemeClr val="accent2"/>
                 </a:solidFill>
@@ -7709,7 +8006,7 @@
               </a:rPr>
               <a:t>₹0</a:t>
             </a:r>
-            <a:endParaRPr lang="en-US" sz="3600" dirty="0"/>
+            <a:endParaRPr lang="en-US" sz="3200" dirty="0"/>
           </a:p>
         </p:txBody>
       </p:sp>
@@ -7721,8 +8018,8 @@
         </p:nvSpPr>
         <p:spPr>
           <a:xfrm>
-            <a:off x="8458200" y="4379976"/>
-            <a:ext cx="2926080" cy="384048"/>
+            <a:off x="8458200" y="3895344"/>
+            <a:ext cx="2926080" cy="292608"/>
           </a:xfrm>
           <a:prstGeom prst="rect">
             <a:avLst/>
@@ -7757,7 +8054,7 @@
         </p:nvSpPr>
         <p:spPr>
           <a:xfrm>
-            <a:off x="8458200" y="4937760"/>
+            <a:off x="8458200" y="4343400"/>
             <a:ext cx="3017520" cy="822960"/>
           </a:xfrm>
           <a:prstGeom prst="rect">
@@ -7806,6 +8103,104 @@
               <a:t>github.com/Tendool/NxtWave-Assignment</a:t>
             </a:r>
             <a:endParaRPr lang="en-US" sz="1000" dirty="0"/>
+          </a:p>
+        </p:txBody>
+      </p:sp>
+      <p:sp>
+        <p:nvSpPr>
+          <p:cNvPr id="36" name="My role strip"/>
+          <p:cNvSpPr/>
+          <p:nvPr/>
+        </p:nvSpPr>
+        <p:spPr>
+          <a:xfrm>
+            <a:off x="548640" y="5541264"/>
+            <a:ext cx="11091672" cy="731520"/>
+          </a:xfrm>
+          <a:prstGeom prst="roundRect">
+            <a:avLst>
+              <a:gd name="adj" fmla="val 7500"/>
+            </a:avLst>
+          </a:prstGeom>
+          <a:solidFill>
+            <a:schemeClr val="accent2"/>
+          </a:solidFill>
+          <a:ln w="19050">
+            <a:solidFill>
+              <a:schemeClr val="tx1"/>
+            </a:solidFill>
+            <a:prstDash val="solid"/>
+          </a:ln>
+          <a:effectLst>
+            <a:outerShdw sx="100000" sy="100000" kx="0" ky="0" algn="bl" rotWithShape="0" blurRad="101600" dist="38100" dir="2700000">
+              <a:srgbClr val="16120E">
+                <a:alpha val="100000"/>
+              </a:srgbClr>
+            </a:outerShdw>
+          </a:effectLst>
+        </p:spPr>
+      </p:sp>
+      <p:sp>
+        <p:nvSpPr>
+          <p:cNvPr id="37" name="My role text"/>
+          <p:cNvSpPr txBox="1"/>
+          <p:nvPr/>
+        </p:nvSpPr>
+        <p:spPr>
+          <a:xfrm>
+            <a:off x="777240" y="5577840"/>
+            <a:ext cx="10698480" cy="658368"/>
+          </a:xfrm>
+          <a:prstGeom prst="rect">
+            <a:avLst/>
+          </a:prstGeom>
+          <a:noFill/>
+          <a:ln/>
+        </p:spPr>
+        <p:txBody>
+          <a:bodyPr wrap="square" lIns="0" tIns="0" rIns="0" bIns="0" rtlCol="0" anchor="ctr"/>
+          <a:lstStyle/>
+          <a:p>
+            <a:pPr indent="0" marL="0">
+              <a:buNone/>
+            </a:pPr>
+            <a:r>
+              <a:rPr lang="en-US" sz="1100" b="1" dirty="0">
+                <a:solidFill>
+                  <a:schemeClr val="accent1"/>
+                </a:solidFill>
+                <a:latin typeface="Courier New" pitchFamily="34" charset="0"/>
+                <a:ea typeface="Courier New" pitchFamily="34" charset="-122"/>
+                <a:cs typeface="Courier New" pitchFamily="34" charset="-120"/>
+              </a:rPr>
+              <a:t>MY ROLE   </a:t>
+            </a:r>
+            <a:pPr indent="0" marL="0">
+              <a:buNone/>
+            </a:pPr>
+            <a:r>
+              <a:rPr lang="en-US" sz="1500" dirty="0">
+                <a:solidFill>
+                  <a:schemeClr val="tx1"/>
+                </a:solidFill>
+                <a:latin typeface="Cambria" pitchFamily="34" charset="0"/>
+                <a:ea typeface="Cambria" pitchFamily="34" charset="-122"/>
+                <a:cs typeface="Cambria" pitchFamily="34" charset="-120"/>
+              </a:rPr>
+              <a:t>I directed, Claude Code built. </a:t>
+            </a:r>
+            <a:pPr indent="0" marL="0">
+              <a:buNone/>
+            </a:pPr>
+            <a:r>
+              <a:rPr lang="en-US" sz="1250" dirty="0">
+                <a:solidFill>
+                  <a:schemeClr val="tx1"/>
+                </a:solidFill>
+              </a:rPr>
+              <a:t>My ideas: the timed challenge with AI-generated variants, local-or-API models behind a password, the full redesign. I checked every build against the brief and sent back what wasn’t right.</a:t>
+            </a:r>
+            <a:endParaRPr lang="en-US" sz="1100" dirty="0"/>
           </a:p>
         </p:txBody>
       </p:sp>

</xml_diff>